<commit_message>
Drop "Video pitch (5-7 min)" from v2 slide footers
Footer now reads "... · 02445 · DTU" on every slide. Deck rebuilt
clean (~0.5 MB).

Co-Authored-By: Claude Opus 4.8 <noreply@anthropic.com>
</commit_message>
<xml_diff>
--- a/defense_presentation/v2/Refusal_Ablation_Defense_v2.pptx
+++ b/defense_presentation/v2/Refusal_Ablation_Defense_v2.pptx
@@ -6218,7 +6218,7 @@
                 </a:solidFill>
                 <a:latin typeface="Calibri"/>
               </a:rPr>
-              <a:t>   ·   02445 · Video pitch (5–7 min) · DTU</a:t>
+              <a:t>   ·   02445 · DTU</a:t>
             </a:r>
           </a:p>
         </p:txBody>
@@ -6889,7 +6889,7 @@
                 </a:solidFill>
                 <a:latin typeface="Calibri"/>
               </a:rPr>
-              <a:t>   ·   02445 · Video pitch (5–7 min) · DTU</a:t>
+              <a:t>   ·   02445 · DTU</a:t>
             </a:r>
           </a:p>
         </p:txBody>
@@ -8915,7 +8915,7 @@
                 </a:solidFill>
                 <a:latin typeface="Calibri"/>
               </a:rPr>
-              <a:t>   ·   02445 · Video pitch (5–7 min) · DTU</a:t>
+              <a:t>   ·   02445 · DTU</a:t>
             </a:r>
           </a:p>
         </p:txBody>
@@ -9693,7 +9693,7 @@
                 </a:solidFill>
                 <a:latin typeface="Calibri"/>
               </a:rPr>
-              <a:t>   ·   02445 · Video pitch (5–7 min) · DTU</a:t>
+              <a:t>   ·   02445 · DTU</a:t>
             </a:r>
           </a:p>
         </p:txBody>
@@ -10289,7 +10289,7 @@
                 </a:solidFill>
                 <a:latin typeface="Calibri"/>
               </a:rPr>
-              <a:t>   ·   02445 · Video pitch (5–7 min) · DTU</a:t>
+              <a:t>   ·   02445 · DTU</a:t>
             </a:r>
           </a:p>
         </p:txBody>
@@ -11407,7 +11407,7 @@
                 </a:solidFill>
                 <a:latin typeface="Calibri"/>
               </a:rPr>
-              <a:t>   ·   02445 · Video pitch (5–7 min) · DTU</a:t>
+              <a:t>   ·   02445 · DTU</a:t>
             </a:r>
           </a:p>
         </p:txBody>
@@ -12837,7 +12837,7 @@
                 </a:solidFill>
                 <a:latin typeface="Calibri"/>
               </a:rPr>
-              <a:t>   ·   02445 · Video pitch (5–7 min) · DTU</a:t>
+              <a:t>   ·   02445 · DTU</a:t>
             </a:r>
           </a:p>
         </p:txBody>
@@ -13790,7 +13790,7 @@
                 </a:solidFill>
                 <a:latin typeface="Calibri"/>
               </a:rPr>
-              <a:t>   ·   02445 · Video pitch (5–7 min) · DTU</a:t>
+              <a:t>   ·   02445 · DTU</a:t>
             </a:r>
           </a:p>
         </p:txBody>
@@ -15047,7 +15047,7 @@
                 </a:solidFill>
                 <a:latin typeface="Calibri"/>
               </a:rPr>
-              <a:t>   ·   02445 · Video pitch (5–7 min) · DTU</a:t>
+              <a:t>   ·   02445 · DTU</a:t>
             </a:r>
           </a:p>
         </p:txBody>
@@ -16153,7 +16153,7 @@
                 </a:solidFill>
                 <a:latin typeface="Calibri"/>
               </a:rPr>
-              <a:t>   ·   02445 · Video pitch (5–7 min) · DTU</a:t>
+              <a:t>   ·   02445 · DTU</a:t>
             </a:r>
           </a:p>
         </p:txBody>
@@ -17301,7 +17301,7 @@
                 </a:solidFill>
                 <a:latin typeface="Calibri"/>
               </a:rPr>
-              <a:t>   ·   02445 · Video pitch (5–7 min) · DTU</a:t>
+              <a:t>   ·   02445 · DTU</a:t>
             </a:r>
           </a:p>
         </p:txBody>
@@ -18354,7 +18354,7 @@
                 </a:solidFill>
                 <a:latin typeface="Calibri"/>
               </a:rPr>
-              <a:t>   ·   02445 · Video pitch (5–7 min) · DTU</a:t>
+              <a:t>   ·   02445 · DTU</a:t>
             </a:r>
           </a:p>
         </p:txBody>
@@ -19146,7 +19146,7 @@
                 </a:solidFill>
                 <a:latin typeface="Calibri"/>
               </a:rPr>
-              <a:t>   ·   02445 · Video pitch (5–7 min) · DTU</a:t>
+              <a:t>   ·   02445 · DTU</a:t>
             </a:r>
           </a:p>
         </p:txBody>

</xml_diff>